<commit_message>
Sin API de Anthropic: solo Jev por API; Claude desde Claude Code
- Se quitan el cliente de Anthropic, los baselines de Sonnet/Opus por API,
  el comentario de Haiku (ahora lo arma el código) y el plan B por API.
- Nuevo npm run compare: priorizar con Jev vs Opus en Claude Code
  (claude -p --model opus), con costo, tiempo de respuesta y criterios,
  grabable para JEV_MODE=replay. Skill jev-vs-opus y comando /compare.
- La priorización registra el tiempo de respuesta; dashboard, costos,
  docs y diapositivas actualizados.

Co-Authored-By: Claude Opus 5.5 <noreply@anthropic.com>
Claude-Session: https://claude.ai/code/session_01TfZy3DqhfSMngJq7utyGCx
</commit_message>
<xml_diff>
--- a/docs/slides/charla-jev.pptx
+++ b/docs/slides/charla-jev.pptx
@@ -13098,7 +13098,7 @@
                 </a:solidFill>
                 <a:latin typeface="Arial"/>
               </a:rPr>
-              <a:t>Pedirle el orden a un LLM grande</a:t>
+              <a:t>Pedirle el orden a Opus (Claude Code)</a:t>
             </a:r>
           </a:p>
         </p:txBody>
@@ -13220,7 +13220,7 @@
                 </a:solidFill>
                 <a:latin typeface="Arial"/>
               </a:rPr>
-              <a:t>Resultado en el ensayo (Opus)</a:t>
+              <a:t>Resultado en el ensayo</a:t>
             </a:r>
           </a:p>
         </p:txBody>
@@ -13291,7 +13291,7 @@
                 </a:solidFill>
                 <a:latin typeface="Arial"/>
               </a:rPr>
-              <a:t>✗ s/d de 5 criterios · s/d</a:t>
+              <a:t>✗ s/d de 5 criterios · s/d · s/d</a:t>
             </a:r>
           </a:p>
         </p:txBody>
@@ -13567,7 +13567,7 @@
                 </a:solidFill>
                 <a:latin typeface="Arial"/>
               </a:rPr>
-              <a:t>✓ s/d de 5 criterios · s/d</a:t>
+              <a:t>✓ s/d de 5 criterios · s/d · s/d</a:t>
             </a:r>
           </a:p>
         </p:txBody>
@@ -14295,7 +14295,7 @@
                 </a:solidFill>
                 <a:latin typeface="Arial"/>
               </a:rPr>
-              <a:t>Solo donde aporta: Sonnet escribe el refactor y Haiku el comentario si hace falta.</a:t>
+              <a:t>Solo donde aporta: Sonnet escribe el refactor en Claude Code.</a:t>
             </a:r>
           </a:p>
         </p:txBody>
@@ -20285,7 +20285,7 @@
                 </a:solidFill>
                 <a:latin typeface="Arial"/>
               </a:rPr>
-              <a:t>Anthropic</a:t>
+              <a:t>Claude Code</a:t>
             </a:r>
           </a:p>
         </p:txBody>
@@ -20324,7 +20324,7 @@
                 </a:solidFill>
                 <a:latin typeface="Arial"/>
               </a:rPr>
-              <a:t>recordings/anthropic</a:t>
+              <a:t>recordings/claude-code</a:t>
             </a:r>
           </a:p>
         </p:txBody>
@@ -22111,7 +22111,7 @@
                 </a:solidFill>
                 <a:latin typeface="Arial"/>
               </a:rPr>
-              <a:t>Priorizar: Jev s/d · Opus s/d</a:t>
+              <a:t>Priorizar: Jev s/d en s/d · Opus s/d en s/d</a:t>
             </a:r>
           </a:p>
           <a:p>
@@ -22143,7 +22143,7 @@
                 </a:solidFill>
                 <a:latin typeface="Arial"/>
               </a:rPr>
-              <a:t>Revisar 5 fixtures: Jev s/d · Opus s/d</a:t>
+              <a:t>Revisar 5 fixtures: Jev s/d · s/d correctos</a:t>
             </a:r>
           </a:p>
         </p:txBody>
@@ -23563,7 +23563,7 @@
                 </a:solidFill>
                 <a:latin typeface="Arial"/>
               </a:rPr>
-              <a:t>Por qué abandonan: Jev clasifica, el código cuenta, Haiku resume.</a:t>
+              <a:t>Por qué abandonan: Jev clasifica, el código cuenta, Claude resume.</a:t>
             </a:r>
           </a:p>
         </p:txBody>

</xml_diff>